<commit_message>
Recolor presentation to black, white and blue-turquoise
Co-Authored-By: Claude Opus 5.5 <noreply@anthropic.com>
Claude-Session: https://claude.ai/code/session_011aKyRVDQdS67c2iiv59yTB
</commit_message>
<xml_diff>
--- a/Seminararbeit/Eigenleistung_Praesentation.pptx
+++ b/Seminararbeit/Eigenleistung_Praesentation.pptx
@@ -116,32 +116,32 @@
   <p:extLst>
     <p:ext uri="{521415D9-36F7-43E2-AB2F-B90AF26B5E84}">
       <p14:sectionLst xmlns:p14="http://schemas.microsoft.com/office/powerpoint/2010/main">
-        <p14:section name="Einstieg" id="{224f78f3-7c1c-0237-f7cd-ebf341230303}">
+        <p14:section name="Einstieg" id="{0e2f3cff-3522-bdf0-717a-9855c794735a}">
           <p14:sldIdLst>
             <p14:sldId id="256"/>
             <p14:sldId id="257"/>
           </p14:sldIdLst>
         </p14:section>
-        <p14:section name="Methode" id="{07c9b433-ae71-4ddd-3e3e-8aa6ea31a73c}">
+        <p14:section name="Methode" id="{0a6bbde9-0141-722f-f6a0-de6a73dc455f}">
           <p14:sldIdLst>
             <p14:sldId id="258"/>
             <p14:sldId id="259"/>
           </p14:sldIdLst>
         </p14:section>
-        <p14:section name="Der Plan" id="{fb5a19bc-2cf2-ce97-d75f-719ef5eaeae4}">
+        <p14:section name="Der Plan" id="{8e6820c4-8319-71fd-8a56-d01b0587841e}">
           <p14:sldIdLst>
             <p14:sldId id="260"/>
             <p14:sldId id="261"/>
             <p14:sldId id="262"/>
           </p14:sldIdLst>
         </p14:section>
-        <p14:section name="Reflexion" id="{5695a3e8-72bb-87e5-1845-1f3c7c51ee58}">
+        <p14:section name="Reflexion" id="{a9894cf9-5d6e-16d2-11d1-9fe4b4ea9362}">
           <p14:sldIdLst>
             <p14:sldId id="263"/>
             <p14:sldId id="264"/>
           </p14:sldIdLst>
         </p14:section>
-        <p14:section name="Anhang" id="{e770557f-5a80-9f67-8149-ca138dec337b}">
+        <p14:section name="Anhang" id="{97edd92f-4ecc-8283-4c53-2062af095097}">
           <p14:sldIdLst>
             <p14:sldId id="265"/>
           </p14:sldIdLst>
@@ -169,7 +169,7 @@
             <a:pPr>
               <a:defRPr sz="1400" b="0" i="0" u="none" strike="noStrike">
                 <a:solidFill>
-                  <a:srgbClr val="0E3B36"/>
+                  <a:srgbClr val="0B0D12"/>
                 </a:solidFill>
                 <a:latin typeface="+mn-lt"/>
               </a:defRPr>
@@ -177,7 +177,7 @@
             <a:r>
               <a:rPr sz="1400" b="0" i="0" u="none" strike="noStrike">
                 <a:solidFill>
-                  <a:srgbClr val="0E3B36"/>
+                  <a:srgbClr val="0B0D12"/>
                 </a:solidFill>
                 <a:latin typeface="+mn-lt"/>
               </a:rPr>
@@ -212,7 +212,7 @@
           </c:tx>
           <c:spPr>
             <a:solidFill>
-              <a:srgbClr val="6FB3A0"/>
+              <a:srgbClr val="2EC4C4"/>
             </a:solidFill>
             <a:effectLst/>
           </c:spPr>
@@ -226,7 +226,7 @@
                 <a:pPr>
                   <a:defRPr b="1" i="0" strike="noStrike" sz="1600" u="none">
                     <a:solidFill>
-                      <a:srgbClr val="13231F"/>
+                      <a:srgbClr val="0A0A0A"/>
                     </a:solidFill>
                     <a:latin typeface="+mn-lt"/>
                   </a:defRPr>
@@ -247,7 +247,7 @@
             <c:bubble3D val="0"/>
             <c:spPr>
               <a:solidFill>
-                <a:srgbClr val="6FB3A0"/>
+                <a:srgbClr val="2EC4C4"/>
               </a:solidFill>
               <a:effectLst/>
             </c:spPr>
@@ -258,7 +258,7 @@
             <c:bubble3D val="0"/>
             <c:spPr>
               <a:solidFill>
-                <a:srgbClr val="1F5E55"/>
+                <a:srgbClr val="0E8A9A"/>
               </a:solidFill>
               <a:effectLst/>
             </c:spPr>
@@ -269,7 +269,7 @@
             <c:bubble3D val="0"/>
             <c:spPr>
               <a:solidFill>
-                <a:srgbClr val="FF6A3D"/>
+                <a:srgbClr val="1565C0"/>
               </a:solidFill>
               <a:effectLst/>
             </c:spPr>
@@ -324,7 +324,7 @@
               <a:pPr>
                 <a:defRPr b="1" i="0" strike="noStrike" sz="1600" u="none">
                   <a:solidFill>
-                    <a:srgbClr val="13231F"/>
+                    <a:srgbClr val="0A0A0A"/>
                   </a:solidFill>
                   <a:latin typeface="+mn-lt"/>
                 </a:defRPr>
@@ -370,7 +370,7 @@
             <a:pPr>
               <a:defRPr sz="1200" b="0" i="0" u="none" strike="noStrike">
                 <a:solidFill>
-                  <a:srgbClr val="13231F"/>
+                  <a:srgbClr val="0A0A0A"/>
                 </a:solidFill>
                 <a:latin typeface="+mn-lt"/>
               </a:defRPr>
@@ -427,7 +427,7 @@
       </c:valAx>
       <c:spPr>
         <a:solidFill>
-          <a:srgbClr val="EEF3F1"/>
+          <a:srgbClr val="F1F5F8"/>
         </a:solidFill>
         <a:ln>
           <a:noFill/>
@@ -2603,7 +2603,7 @@
             </a:avLst>
           </a:prstGeom>
           <a:solidFill>
-            <a:schemeClr val="accent1"/>
+            <a:schemeClr val="accent2"/>
           </a:solidFill>
           <a:ln/>
         </p:spPr>
@@ -2625,7 +2625,7 @@
             </a:avLst>
           </a:prstGeom>
           <a:solidFill>
-            <a:schemeClr val="accent1"/>
+            <a:schemeClr val="accent2"/>
           </a:solidFill>
           <a:ln/>
         </p:spPr>
@@ -2647,7 +2647,7 @@
             </a:avLst>
           </a:prstGeom>
           <a:solidFill>
-            <a:schemeClr val="accent1"/>
+            <a:schemeClr val="accent2"/>
           </a:solidFill>
           <a:ln/>
         </p:spPr>
@@ -2669,8 +2669,8 @@
             </a:avLst>
           </a:prstGeom>
           <a:solidFill>
-            <a:schemeClr val="accent2">
-              <a:alpha val="80000"/>
+            <a:schemeClr val="bg1">
+              <a:alpha val="22000"/>
             </a:schemeClr>
           </a:solidFill>
           <a:ln/>
@@ -2693,8 +2693,8 @@
             </a:avLst>
           </a:prstGeom>
           <a:solidFill>
-            <a:schemeClr val="accent2">
-              <a:alpha val="80000"/>
+            <a:schemeClr val="bg1">
+              <a:alpha val="22000"/>
             </a:schemeClr>
           </a:solidFill>
           <a:ln/>
@@ -2717,8 +2717,8 @@
             </a:avLst>
           </a:prstGeom>
           <a:solidFill>
-            <a:schemeClr val="accent2">
-              <a:alpha val="80000"/>
+            <a:schemeClr val="bg1">
+              <a:alpha val="22000"/>
             </a:schemeClr>
           </a:solidFill>
           <a:ln/>
@@ -2741,8 +2741,8 @@
             </a:avLst>
           </a:prstGeom>
           <a:solidFill>
-            <a:schemeClr val="accent2">
-              <a:alpha val="80000"/>
+            <a:schemeClr val="bg1">
+              <a:alpha val="22000"/>
             </a:schemeClr>
           </a:solidFill>
           <a:ln/>
@@ -2765,8 +2765,8 @@
             </a:avLst>
           </a:prstGeom>
           <a:solidFill>
-            <a:schemeClr val="accent2">
-              <a:alpha val="80000"/>
+            <a:schemeClr val="bg1">
+              <a:alpha val="22000"/>
             </a:schemeClr>
           </a:solidFill>
           <a:ln/>
@@ -2789,8 +2789,8 @@
             </a:avLst>
           </a:prstGeom>
           <a:solidFill>
-            <a:schemeClr val="accent2">
-              <a:alpha val="80000"/>
+            <a:schemeClr val="bg1">
+              <a:alpha val="22000"/>
             </a:schemeClr>
           </a:solidFill>
           <a:ln/>
@@ -2989,7 +2989,7 @@
                       <a:tailEnd type="none" w="med" len="med"/>
                     </a:lnB>
                     <a:solidFill>
-                      <a:srgbClr val="0E3B36"/>
+                      <a:srgbClr val="0B0D12"/>
                     </a:solidFill>
                   </a:tcPr>
                 </a:tc>
@@ -3057,7 +3057,7 @@
                       <a:tailEnd type="none" w="med" len="med"/>
                     </a:lnB>
                     <a:solidFill>
-                      <a:srgbClr val="0E3B36"/>
+                      <a:srgbClr val="0B0D12"/>
                     </a:solidFill>
                   </a:tcPr>
                 </a:tc>
@@ -3074,7 +3074,7 @@
                       <a:r>
                         <a:rPr lang="en-US" sz="1400" dirty="0">
                           <a:solidFill>
-                            <a:srgbClr val="13231F"/>
+                            <a:srgbClr val="0A0A0A"/>
                           </a:solidFill>
                           <a:latin typeface="Calibri" pitchFamily="34" charset="0"/>
                           <a:ea typeface="Calibri" pitchFamily="34" charset="-122"/>
@@ -3142,7 +3142,7 @@
                       <a:r>
                         <a:rPr lang="en-US" sz="1400" dirty="0">
                           <a:solidFill>
-                            <a:srgbClr val="13231F"/>
+                            <a:srgbClr val="0A0A0A"/>
                           </a:solidFill>
                           <a:latin typeface="Calibri" pitchFamily="34" charset="0"/>
                           <a:ea typeface="Calibri" pitchFamily="34" charset="-122"/>
@@ -3212,7 +3212,7 @@
                       <a:r>
                         <a:rPr lang="en-US" sz="1400" dirty="0">
                           <a:solidFill>
-                            <a:srgbClr val="13231F"/>
+                            <a:srgbClr val="0A0A0A"/>
                           </a:solidFill>
                           <a:latin typeface="Calibri" pitchFamily="34" charset="0"/>
                           <a:ea typeface="Calibri" pitchFamily="34" charset="-122"/>
@@ -3280,7 +3280,7 @@
                       <a:r>
                         <a:rPr lang="en-US" sz="1400" dirty="0">
                           <a:solidFill>
-                            <a:srgbClr val="13231F"/>
+                            <a:srgbClr val="0A0A0A"/>
                           </a:solidFill>
                           <a:latin typeface="Calibri" pitchFamily="34" charset="0"/>
                           <a:ea typeface="Calibri" pitchFamily="34" charset="-122"/>
@@ -3350,7 +3350,7 @@
                       <a:r>
                         <a:rPr lang="en-US" sz="1400" dirty="0">
                           <a:solidFill>
-                            <a:srgbClr val="13231F"/>
+                            <a:srgbClr val="0A0A0A"/>
                           </a:solidFill>
                           <a:latin typeface="Calibri" pitchFamily="34" charset="0"/>
                           <a:ea typeface="Calibri" pitchFamily="34" charset="-122"/>
@@ -3418,7 +3418,7 @@
                       <a:r>
                         <a:rPr lang="en-US" sz="1400" dirty="0">
                           <a:solidFill>
-                            <a:srgbClr val="13231F"/>
+                            <a:srgbClr val="0A0A0A"/>
                           </a:solidFill>
                           <a:latin typeface="Calibri" pitchFamily="34" charset="0"/>
                           <a:ea typeface="Calibri" pitchFamily="34" charset="-122"/>
@@ -3488,7 +3488,7 @@
                       <a:r>
                         <a:rPr lang="en-US" sz="1400" dirty="0">
                           <a:solidFill>
-                            <a:srgbClr val="13231F"/>
+                            <a:srgbClr val="0A0A0A"/>
                           </a:solidFill>
                           <a:latin typeface="Calibri" pitchFamily="34" charset="0"/>
                           <a:ea typeface="Calibri" pitchFamily="34" charset="-122"/>
@@ -3556,7 +3556,7 @@
                       <a:r>
                         <a:rPr lang="en-US" sz="1400" dirty="0">
                           <a:solidFill>
-                            <a:srgbClr val="13231F"/>
+                            <a:srgbClr val="0A0A0A"/>
                           </a:solidFill>
                           <a:latin typeface="Calibri" pitchFamily="34" charset="0"/>
                           <a:ea typeface="Calibri" pitchFamily="34" charset="-122"/>
@@ -3626,7 +3626,7 @@
                       <a:r>
                         <a:rPr lang="en-US" sz="1400" dirty="0">
                           <a:solidFill>
-                            <a:srgbClr val="13231F"/>
+                            <a:srgbClr val="0A0A0A"/>
                           </a:solidFill>
                           <a:latin typeface="Calibri" pitchFamily="34" charset="0"/>
                           <a:ea typeface="Calibri" pitchFamily="34" charset="-122"/>
@@ -3694,7 +3694,7 @@
                       <a:r>
                         <a:rPr lang="en-US" sz="1400" dirty="0">
                           <a:solidFill>
-                            <a:srgbClr val="13231F"/>
+                            <a:srgbClr val="0A0A0A"/>
                           </a:solidFill>
                           <a:latin typeface="Calibri" pitchFamily="34" charset="0"/>
                           <a:ea typeface="Calibri" pitchFamily="34" charset="-122"/>
@@ -3764,7 +3764,7 @@
                       <a:r>
                         <a:rPr lang="en-US" sz="1400" dirty="0">
                           <a:solidFill>
-                            <a:srgbClr val="13231F"/>
+                            <a:srgbClr val="0A0A0A"/>
                           </a:solidFill>
                           <a:latin typeface="Calibri" pitchFamily="34" charset="0"/>
                           <a:ea typeface="Calibri" pitchFamily="34" charset="-122"/>
@@ -3832,7 +3832,7 @@
                       <a:r>
                         <a:rPr lang="en-US" sz="1400" dirty="0">
                           <a:solidFill>
-                            <a:srgbClr val="13231F"/>
+                            <a:srgbClr val="0A0A0A"/>
                           </a:solidFill>
                           <a:latin typeface="Calibri" pitchFamily="34" charset="0"/>
                           <a:ea typeface="Calibri" pitchFamily="34" charset="-122"/>
@@ -3902,7 +3902,7 @@
                       <a:r>
                         <a:rPr lang="en-US" sz="1400" dirty="0">
                           <a:solidFill>
-                            <a:srgbClr val="13231F"/>
+                            <a:srgbClr val="0A0A0A"/>
                           </a:solidFill>
                           <a:latin typeface="Calibri" pitchFamily="34" charset="0"/>
                           <a:ea typeface="Calibri" pitchFamily="34" charset="-122"/>
@@ -3970,7 +3970,7 @@
                       <a:r>
                         <a:rPr lang="en-US" sz="1400" dirty="0">
                           <a:solidFill>
-                            <a:srgbClr val="13231F"/>
+                            <a:srgbClr val="0A0A0A"/>
                           </a:solidFill>
                           <a:latin typeface="Calibri" pitchFamily="34" charset="0"/>
                           <a:ea typeface="Calibri" pitchFamily="34" charset="-122"/>
@@ -4040,7 +4040,7 @@
                       <a:r>
                         <a:rPr lang="en-US" sz="1400" dirty="0">
                           <a:solidFill>
-                            <a:srgbClr val="13231F"/>
+                            <a:srgbClr val="0A0A0A"/>
                           </a:solidFill>
                           <a:latin typeface="Calibri" pitchFamily="34" charset="0"/>
                           <a:ea typeface="Calibri" pitchFamily="34" charset="-122"/>
@@ -4108,7 +4108,7 @@
                       <a:r>
                         <a:rPr lang="en-US" sz="1400" dirty="0">
                           <a:solidFill>
-                            <a:srgbClr val="13231F"/>
+                            <a:srgbClr val="0A0A0A"/>
                           </a:solidFill>
                           <a:latin typeface="Calibri" pitchFamily="34" charset="0"/>
                           <a:ea typeface="Calibri" pitchFamily="34" charset="-122"/>
@@ -9271,7 +9271,7 @@
             <a:r>
               <a:rPr lang="en-US" sz="6600" b="1" dirty="0">
                 <a:solidFill>
-                  <a:schemeClr val="accent1"/>
+                  <a:schemeClr val="accent2"/>
                 </a:solidFill>
                 <a:latin typeface="Cambria" pitchFamily="34" charset="0"/>
                 <a:ea typeface="Cambria" pitchFamily="34" charset="-122"/>
@@ -9346,7 +9346,7 @@
             <a:r>
               <a:rPr lang="en-US" sz="6600" b="1" dirty="0">
                 <a:solidFill>
-                  <a:schemeClr val="accent1"/>
+                  <a:schemeClr val="accent2"/>
                 </a:solidFill>
                 <a:latin typeface="Cambria" pitchFamily="34" charset="0"/>
                 <a:ea typeface="Cambria" pitchFamily="34" charset="-122"/>
@@ -9421,7 +9421,7 @@
             <a:r>
               <a:rPr lang="en-US" sz="6600" b="1" dirty="0">
                 <a:solidFill>
-                  <a:schemeClr val="accent1"/>
+                  <a:schemeClr val="accent2"/>
                 </a:solidFill>
                 <a:latin typeface="Cambria" pitchFamily="34" charset="0"/>
                 <a:ea typeface="Cambria" pitchFamily="34" charset="-122"/>
@@ -9558,7 +9558,7 @@
             </a:avLst>
           </a:prstGeom>
           <a:solidFill>
-            <a:schemeClr val="accent1"/>
+            <a:schemeClr val="accent2"/>
           </a:solidFill>
           <a:ln/>
         </p:spPr>
@@ -9580,7 +9580,7 @@
             </a:avLst>
           </a:prstGeom>
           <a:solidFill>
-            <a:schemeClr val="accent1"/>
+            <a:schemeClr val="accent2"/>
           </a:solidFill>
           <a:ln/>
         </p:spPr>
@@ -9602,7 +9602,7 @@
             </a:avLst>
           </a:prstGeom>
           <a:solidFill>
-            <a:schemeClr val="accent1"/>
+            <a:schemeClr val="accent2"/>
           </a:solidFill>
           <a:ln/>
         </p:spPr>
@@ -9624,8 +9624,8 @@
             </a:avLst>
           </a:prstGeom>
           <a:solidFill>
-            <a:schemeClr val="accent2">
-              <a:alpha val="80000"/>
+            <a:schemeClr val="bg1">
+              <a:alpha val="22000"/>
             </a:schemeClr>
           </a:solidFill>
           <a:ln/>
@@ -9648,8 +9648,8 @@
             </a:avLst>
           </a:prstGeom>
           <a:solidFill>
-            <a:schemeClr val="accent2">
-              <a:alpha val="80000"/>
+            <a:schemeClr val="bg1">
+              <a:alpha val="22000"/>
             </a:schemeClr>
           </a:solidFill>
           <a:ln/>
@@ -9672,8 +9672,8 @@
             </a:avLst>
           </a:prstGeom>
           <a:solidFill>
-            <a:schemeClr val="accent2">
-              <a:alpha val="80000"/>
+            <a:schemeClr val="bg1">
+              <a:alpha val="22000"/>
             </a:schemeClr>
           </a:solidFill>
           <a:ln/>
@@ -9696,8 +9696,8 @@
             </a:avLst>
           </a:prstGeom>
           <a:solidFill>
-            <a:schemeClr val="accent2">
-              <a:alpha val="80000"/>
+            <a:schemeClr val="bg1">
+              <a:alpha val="22000"/>
             </a:schemeClr>
           </a:solidFill>
           <a:ln/>
@@ -9720,8 +9720,8 @@
             </a:avLst>
           </a:prstGeom>
           <a:solidFill>
-            <a:schemeClr val="accent2">
-              <a:alpha val="80000"/>
+            <a:schemeClr val="bg1">
+              <a:alpha val="22000"/>
             </a:schemeClr>
           </a:solidFill>
           <a:ln/>
@@ -9744,8 +9744,8 @@
             </a:avLst>
           </a:prstGeom>
           <a:solidFill>
-            <a:schemeClr val="accent2">
-              <a:alpha val="80000"/>
+            <a:schemeClr val="bg1">
+              <a:alpha val="22000"/>
             </a:schemeClr>
           </a:solidFill>
           <a:ln/>
@@ -9800,40 +9800,40 @@
   <a:themeElements>
     <a:clrScheme name="Aufrecht">
       <a:dk1>
-        <a:srgbClr val="13231F"/>
+        <a:srgbClr val="0A0A0A"/>
       </a:dk1>
       <a:lt1>
         <a:srgbClr val="FFFFFF"/>
       </a:lt1>
       <a:dk2>
-        <a:srgbClr val="0E3B36"/>
+        <a:srgbClr val="0B0D12"/>
       </a:dk2>
       <a:lt2>
-        <a:srgbClr val="EEF3F1"/>
+        <a:srgbClr val="F1F5F8"/>
       </a:lt2>
       <a:accent1>
-        <a:srgbClr val="FF6A3D"/>
+        <a:srgbClr val="1565C0"/>
       </a:accent1>
       <a:accent2>
-        <a:srgbClr val="6FB3A0"/>
+        <a:srgbClr val="2EC4C4"/>
       </a:accent2>
       <a:accent3>
-        <a:srgbClr val="1F5E55"/>
+        <a:srgbClr val="0E8A9A"/>
       </a:accent3>
       <a:accent4>
-        <a:srgbClr val="FFE3D9"/>
+        <a:srgbClr val="E3EEFB"/>
       </a:accent4>
       <a:accent5>
-        <a:srgbClr val="DCEDE7"/>
+        <a:srgbClr val="DDF4F4"/>
       </a:accent5>
       <a:accent6>
-        <a:srgbClr val="6B7C78"/>
+        <a:srgbClr val="6B7280"/>
       </a:accent6>
       <a:hlink>
-        <a:srgbClr val="FF6A3D"/>
+        <a:srgbClr val="1565C0"/>
       </a:hlink>
       <a:folHlink>
-        <a:srgbClr val="1F5E55"/>
+        <a:srgbClr val="0E8A9A"/>
       </a:folHlink>
     </a:clrScheme>
     <a:fontScheme name="Aufrecht">

</xml_diff>

<commit_message>
Draw anatomically shaped spine (side view) on title and closing slides
Co-Authored-By: Claude Opus 5.5 <noreply@anthropic.com>
Claude-Session: https://claude.ai/code/session_011aKyRVDQdS67c2iiv59yTB
</commit_message>
<xml_diff>
--- a/Seminararbeit/Eigenleistung_Praesentation.pptx
+++ b/Seminararbeit/Eigenleistung_Praesentation.pptx
@@ -116,32 +116,32 @@
   <p:extLst>
     <p:ext uri="{521415D9-36F7-43E2-AB2F-B90AF26B5E84}">
       <p14:sectionLst xmlns:p14="http://schemas.microsoft.com/office/powerpoint/2010/main">
-        <p14:section name="Einstieg" id="{0e2f3cff-3522-bdf0-717a-9855c794735a}">
+        <p14:section name="Einstieg" id="{5aea64f5-d50b-799a-b364-cfd61923e774}">
           <p14:sldIdLst>
             <p14:sldId id="256"/>
             <p14:sldId id="257"/>
           </p14:sldIdLst>
         </p14:section>
-        <p14:section name="Methode" id="{0a6bbde9-0141-722f-f6a0-de6a73dc455f}">
+        <p14:section name="Methode" id="{080cfec9-dca2-de11-aeab-060d687ce054}">
           <p14:sldIdLst>
             <p14:sldId id="258"/>
             <p14:sldId id="259"/>
           </p14:sldIdLst>
         </p14:section>
-        <p14:section name="Der Plan" id="{8e6820c4-8319-71fd-8a56-d01b0587841e}">
+        <p14:section name="Der Plan" id="{af9b694c-f795-aa1f-a21b-aa989167f153}">
           <p14:sldIdLst>
             <p14:sldId id="260"/>
             <p14:sldId id="261"/>
             <p14:sldId id="262"/>
           </p14:sldIdLst>
         </p14:section>
-        <p14:section name="Reflexion" id="{a9894cf9-5d6e-16d2-11d1-9fe4b4ea9362}">
+        <p14:section name="Reflexion" id="{abe071bd-eead-2cdd-1b33-8cbe84c2fc7e}">
           <p14:sldIdLst>
             <p14:sldId id="263"/>
             <p14:sldId id="264"/>
           </p14:sldIdLst>
         </p14:section>
-        <p14:section name="Anhang" id="{97edd92f-4ecc-8283-4c53-2062af095097}">
+        <p14:section name="Anhang" id="{481a9fc4-112b-6efd-0a0d-bb091535cd0a}">
           <p14:sldIdLst>
             <p14:sldId id="265"/>
           </p14:sldIdLst>
@@ -1638,7 +1638,7 @@
           <a:p>
             <a:r>
               <a:rPr lang="en-US" dirty="0"/>
-              <a:t>Zum Schluss: Mein Plan ist kein Wundermittel, aber ein realistischer Weg zu einer besseren Haltung. 20 Minuten ohne Geräte, neun Übungen in drei Phasen und ein Video, das alles zeigt. Erinnert ihr euch an die Wirbelsäule vom Anfang? Genau da soll es hingehen. Danke fürs Zuhören! Ich freue mich über eure Fragen und kritischen Anmerkungen, denn die kann ich noch in die Arbeit einbauen. Und eine Frage an euch: Würdet ihr diese 20 Minuten in eurer Mittagspause investieren? (ca. 30 Sekunden)</a:t>
+              <a:t>Zum Schluss: Mein Plan ist kein Wundermittel, aber ein realistischer Weg zu einer besseren Haltung. 20 Minuten ohne Geräte, neun Übungen in drei Phasen und ein Video, das alles zeigt. Erinnert ihr euch an die Wirbelsäule vom Anfang, mit dem Kopf weit vor dem Körper? Ziel ist die natürliche S-Form hier rechts: nicht kerzengerade, sondern Kopf, Wirbelsäule und Becken wieder auf einer Linie. Danke fürs Zuhören! Ich freue mich über eure Fragen und kritischen Anmerkungen, denn die kann ich noch in die Arbeit einbauen. Und eine Frage an euch: Würdet ihr diese 20 Minuten in eurer Mittagspause investieren? (ca. 30 Sekunden)</a:t>
             </a:r>
             <a:endParaRPr lang="en-US" dirty="0"/>
           </a:p>
@@ -2586,219 +2586,33 @@
           </a:p>
         </p:txBody>
       </p:sp>
-      <p:sp>
-        <p:nvSpPr>
-          <p:cNvPr id="6" name="Wirbel 1"/>
-          <p:cNvSpPr/>
-          <p:nvPr/>
-        </p:nvSpPr>
-        <p:spPr>
-          <a:xfrm>
-            <a:off x="8229600" y="1280160"/>
-            <a:ext cx="1371600" cy="365760"/>
-          </a:xfrm>
-          <a:prstGeom prst="roundRect">
-            <a:avLst>
-              <a:gd name="adj" fmla="val 50000"/>
-            </a:avLst>
-          </a:prstGeom>
-          <a:solidFill>
-            <a:schemeClr val="accent2"/>
-          </a:solidFill>
-          <a:ln/>
-        </p:spPr>
-      </p:sp>
-      <p:sp>
-        <p:nvSpPr>
-          <p:cNvPr id="7" name="Wirbel 2"/>
-          <p:cNvSpPr/>
-          <p:nvPr/>
-        </p:nvSpPr>
-        <p:spPr>
-          <a:xfrm>
-            <a:off x="8549640" y="1755648"/>
-            <a:ext cx="1371600" cy="365760"/>
-          </a:xfrm>
-          <a:prstGeom prst="roundRect">
-            <a:avLst>
-              <a:gd name="adj" fmla="val 50000"/>
-            </a:avLst>
-          </a:prstGeom>
-          <a:solidFill>
-            <a:schemeClr val="accent2"/>
-          </a:solidFill>
-          <a:ln/>
-        </p:spPr>
-      </p:sp>
-      <p:sp>
-        <p:nvSpPr>
-          <p:cNvPr id="8" name="Wirbel 3"/>
-          <p:cNvSpPr/>
-          <p:nvPr/>
-        </p:nvSpPr>
-        <p:spPr>
-          <a:xfrm>
-            <a:off x="8823960" y="2231136"/>
-            <a:ext cx="1371600" cy="365760"/>
-          </a:xfrm>
-          <a:prstGeom prst="roundRect">
-            <a:avLst>
-              <a:gd name="adj" fmla="val 50000"/>
-            </a:avLst>
-          </a:prstGeom>
-          <a:solidFill>
-            <a:schemeClr val="accent2"/>
-          </a:solidFill>
-          <a:ln/>
-        </p:spPr>
-      </p:sp>
-      <p:sp>
-        <p:nvSpPr>
-          <p:cNvPr id="9" name="Wirbel 4"/>
-          <p:cNvSpPr/>
-          <p:nvPr/>
-        </p:nvSpPr>
-        <p:spPr>
-          <a:xfrm>
-            <a:off x="9052560" y="2706624"/>
-            <a:ext cx="1371600" cy="365760"/>
-          </a:xfrm>
-          <a:prstGeom prst="roundRect">
-            <a:avLst>
-              <a:gd name="adj" fmla="val 50000"/>
-            </a:avLst>
-          </a:prstGeom>
-          <a:solidFill>
-            <a:schemeClr val="bg1">
-              <a:alpha val="22000"/>
-            </a:schemeClr>
-          </a:solidFill>
-          <a:ln/>
-        </p:spPr>
-      </p:sp>
-      <p:sp>
-        <p:nvSpPr>
-          <p:cNvPr id="10" name="Wirbel 5"/>
-          <p:cNvSpPr/>
-          <p:nvPr/>
-        </p:nvSpPr>
-        <p:spPr>
-          <a:xfrm>
-            <a:off x="9162288" y="3182112"/>
-            <a:ext cx="1371600" cy="365760"/>
-          </a:xfrm>
-          <a:prstGeom prst="roundRect">
-            <a:avLst>
-              <a:gd name="adj" fmla="val 50000"/>
-            </a:avLst>
-          </a:prstGeom>
-          <a:solidFill>
-            <a:schemeClr val="bg1">
-              <a:alpha val="22000"/>
-            </a:schemeClr>
-          </a:solidFill>
-          <a:ln/>
-        </p:spPr>
-      </p:sp>
-      <p:sp>
-        <p:nvSpPr>
-          <p:cNvPr id="11" name="Wirbel 6"/>
-          <p:cNvSpPr/>
-          <p:nvPr/>
-        </p:nvSpPr>
-        <p:spPr>
-          <a:xfrm>
-            <a:off x="9162288" y="3657600"/>
-            <a:ext cx="1371600" cy="365760"/>
-          </a:xfrm>
-          <a:prstGeom prst="roundRect">
-            <a:avLst>
-              <a:gd name="adj" fmla="val 50000"/>
-            </a:avLst>
-          </a:prstGeom>
-          <a:solidFill>
-            <a:schemeClr val="bg1">
-              <a:alpha val="22000"/>
-            </a:schemeClr>
-          </a:solidFill>
-          <a:ln/>
-        </p:spPr>
-      </p:sp>
-      <p:sp>
-        <p:nvSpPr>
-          <p:cNvPr id="12" name="Wirbel 7"/>
-          <p:cNvSpPr/>
-          <p:nvPr/>
-        </p:nvSpPr>
-        <p:spPr>
-          <a:xfrm>
-            <a:off x="9070848" y="4133088"/>
-            <a:ext cx="1371600" cy="365760"/>
-          </a:xfrm>
-          <a:prstGeom prst="roundRect">
-            <a:avLst>
-              <a:gd name="adj" fmla="val 50000"/>
-            </a:avLst>
-          </a:prstGeom>
-          <a:solidFill>
-            <a:schemeClr val="bg1">
-              <a:alpha val="22000"/>
-            </a:schemeClr>
-          </a:solidFill>
-          <a:ln/>
-        </p:spPr>
-      </p:sp>
-      <p:sp>
-        <p:nvSpPr>
-          <p:cNvPr id="13" name="Wirbel 8"/>
-          <p:cNvSpPr/>
-          <p:nvPr/>
-        </p:nvSpPr>
-        <p:spPr>
-          <a:xfrm>
-            <a:off x="8942832" y="4608576"/>
-            <a:ext cx="1371600" cy="365760"/>
-          </a:xfrm>
-          <a:prstGeom prst="roundRect">
-            <a:avLst>
-              <a:gd name="adj" fmla="val 50000"/>
-            </a:avLst>
-          </a:prstGeom>
-          <a:solidFill>
-            <a:schemeClr val="bg1">
-              <a:alpha val="22000"/>
-            </a:schemeClr>
-          </a:solidFill>
-          <a:ln/>
-        </p:spPr>
-      </p:sp>
-      <p:sp>
-        <p:nvSpPr>
-          <p:cNvPr id="14" name="Wirbel 9"/>
-          <p:cNvSpPr/>
-          <p:nvPr/>
-        </p:nvSpPr>
-        <p:spPr>
-          <a:xfrm>
-            <a:off x="8823960" y="5084064"/>
-            <a:ext cx="1371600" cy="365760"/>
-          </a:xfrm>
-          <a:prstGeom prst="roundRect">
-            <a:avLst>
-              <a:gd name="adj" fmla="val 50000"/>
-            </a:avLst>
-          </a:prstGeom>
-          <a:solidFill>
-            <a:schemeClr val="bg1">
-              <a:alpha val="22000"/>
-            </a:schemeClr>
-          </a:solidFill>
-          <a:ln/>
-        </p:spPr>
-      </p:sp>
-      <p:sp>
-        <p:nvSpPr>
-          <p:cNvPr id="15" name="Text 13"/>
+      <p:pic>
+        <p:nvPicPr>
+          <p:cNvPr id="6" name="Image 0" descr="Wirbelsäule in Sitzhaltung mit vorgeschobenem Kopf, seitlich">    </p:cNvPr>
+          <p:cNvPicPr>
+            <a:picLocks noChangeAspect="1"/>
+          </p:cNvPicPr>
+          <p:nvPr/>
+        </p:nvPicPr>
+        <p:blipFill>
+          <a:blip r:embed="rId1"/>
+          <a:stretch>
+            <a:fillRect/>
+          </a:stretch>
+        </p:blipFill>
+        <p:spPr>
+          <a:xfrm>
+            <a:off x="8869680" y="548640"/>
+            <a:ext cx="2212848" cy="5029200"/>
+          </a:xfrm>
+          <a:prstGeom prst="rect">
+            <a:avLst/>
+          </a:prstGeom>
+        </p:spPr>
+      </p:pic>
+      <p:sp>
+        <p:nvSpPr>
+          <p:cNvPr id="7" name="Text 4"/>
           <p:cNvSpPr txBox="1"/>
           <p:nvPr/>
         </p:nvSpPr>
@@ -2826,7 +2640,7 @@
                   <a:schemeClr val="accent2"/>
                 </a:solidFill>
               </a:rPr>
-              <a:t>Kopf vor, Schultern rund: die Haltung nach einem langen Schultag</a:t>
+              <a:t>Kopf vor, Rücken rund: die Haltung nach einem langen Schultag</a:t>
             </a:r>
             <a:endParaRPr lang="en-US" sz="1100" dirty="0"/>
           </a:p>
@@ -9541,226 +9355,40 @@
           </a:p>
         </p:txBody>
       </p:sp>
-      <p:sp>
-        <p:nvSpPr>
-          <p:cNvPr id="11" name="Wirbel 1"/>
-          <p:cNvSpPr/>
-          <p:nvPr/>
-        </p:nvSpPr>
-        <p:spPr>
-          <a:xfrm>
-            <a:off x="9509760" y="1280160"/>
-            <a:ext cx="1371600" cy="365760"/>
-          </a:xfrm>
-          <a:prstGeom prst="roundRect">
-            <a:avLst>
-              <a:gd name="adj" fmla="val 50000"/>
-            </a:avLst>
-          </a:prstGeom>
-          <a:solidFill>
-            <a:schemeClr val="accent2"/>
-          </a:solidFill>
-          <a:ln/>
-        </p:spPr>
-      </p:sp>
-      <p:sp>
-        <p:nvSpPr>
-          <p:cNvPr id="12" name="Wirbel 2"/>
-          <p:cNvSpPr/>
-          <p:nvPr/>
-        </p:nvSpPr>
-        <p:spPr>
-          <a:xfrm>
-            <a:off x="9509760" y="1755648"/>
-            <a:ext cx="1371600" cy="365760"/>
-          </a:xfrm>
-          <a:prstGeom prst="roundRect">
-            <a:avLst>
-              <a:gd name="adj" fmla="val 50000"/>
-            </a:avLst>
-          </a:prstGeom>
-          <a:solidFill>
-            <a:schemeClr val="accent2"/>
-          </a:solidFill>
-          <a:ln/>
-        </p:spPr>
-      </p:sp>
-      <p:sp>
-        <p:nvSpPr>
-          <p:cNvPr id="13" name="Wirbel 3"/>
-          <p:cNvSpPr/>
-          <p:nvPr/>
-        </p:nvSpPr>
-        <p:spPr>
-          <a:xfrm>
-            <a:off x="9509760" y="2231136"/>
-            <a:ext cx="1371600" cy="365760"/>
-          </a:xfrm>
-          <a:prstGeom prst="roundRect">
-            <a:avLst>
-              <a:gd name="adj" fmla="val 50000"/>
-            </a:avLst>
-          </a:prstGeom>
-          <a:solidFill>
-            <a:schemeClr val="accent2"/>
-          </a:solidFill>
-          <a:ln/>
-        </p:spPr>
-      </p:sp>
-      <p:sp>
-        <p:nvSpPr>
-          <p:cNvPr id="14" name="Wirbel 4"/>
-          <p:cNvSpPr/>
-          <p:nvPr/>
-        </p:nvSpPr>
-        <p:spPr>
-          <a:xfrm>
-            <a:off x="9509760" y="2706624"/>
-            <a:ext cx="1371600" cy="365760"/>
-          </a:xfrm>
-          <a:prstGeom prst="roundRect">
-            <a:avLst>
-              <a:gd name="adj" fmla="val 50000"/>
-            </a:avLst>
-          </a:prstGeom>
-          <a:solidFill>
-            <a:schemeClr val="bg1">
-              <a:alpha val="22000"/>
-            </a:schemeClr>
-          </a:solidFill>
-          <a:ln/>
-        </p:spPr>
-      </p:sp>
-      <p:sp>
-        <p:nvSpPr>
-          <p:cNvPr id="15" name="Wirbel 5"/>
-          <p:cNvSpPr/>
-          <p:nvPr/>
-        </p:nvSpPr>
-        <p:spPr>
-          <a:xfrm>
-            <a:off x="9509760" y="3182112"/>
-            <a:ext cx="1371600" cy="365760"/>
-          </a:xfrm>
-          <a:prstGeom prst="roundRect">
-            <a:avLst>
-              <a:gd name="adj" fmla="val 50000"/>
-            </a:avLst>
-          </a:prstGeom>
-          <a:solidFill>
-            <a:schemeClr val="bg1">
-              <a:alpha val="22000"/>
-            </a:schemeClr>
-          </a:solidFill>
-          <a:ln/>
-        </p:spPr>
-      </p:sp>
-      <p:sp>
-        <p:nvSpPr>
-          <p:cNvPr id="16" name="Wirbel 6"/>
-          <p:cNvSpPr/>
-          <p:nvPr/>
-        </p:nvSpPr>
-        <p:spPr>
-          <a:xfrm>
-            <a:off x="9509760" y="3657600"/>
-            <a:ext cx="1371600" cy="365760"/>
-          </a:xfrm>
-          <a:prstGeom prst="roundRect">
-            <a:avLst>
-              <a:gd name="adj" fmla="val 50000"/>
-            </a:avLst>
-          </a:prstGeom>
-          <a:solidFill>
-            <a:schemeClr val="bg1">
-              <a:alpha val="22000"/>
-            </a:schemeClr>
-          </a:solidFill>
-          <a:ln/>
-        </p:spPr>
-      </p:sp>
-      <p:sp>
-        <p:nvSpPr>
-          <p:cNvPr id="17" name="Wirbel 7"/>
-          <p:cNvSpPr/>
-          <p:nvPr/>
-        </p:nvSpPr>
-        <p:spPr>
-          <a:xfrm>
-            <a:off x="9509760" y="4133088"/>
-            <a:ext cx="1371600" cy="365760"/>
-          </a:xfrm>
-          <a:prstGeom prst="roundRect">
-            <a:avLst>
-              <a:gd name="adj" fmla="val 50000"/>
-            </a:avLst>
-          </a:prstGeom>
-          <a:solidFill>
-            <a:schemeClr val="bg1">
-              <a:alpha val="22000"/>
-            </a:schemeClr>
-          </a:solidFill>
-          <a:ln/>
-        </p:spPr>
-      </p:sp>
-      <p:sp>
-        <p:nvSpPr>
-          <p:cNvPr id="18" name="Wirbel 8"/>
-          <p:cNvSpPr/>
-          <p:nvPr/>
-        </p:nvSpPr>
-        <p:spPr>
-          <a:xfrm>
-            <a:off x="9509760" y="4608576"/>
-            <a:ext cx="1371600" cy="365760"/>
-          </a:xfrm>
-          <a:prstGeom prst="roundRect">
-            <a:avLst>
-              <a:gd name="adj" fmla="val 50000"/>
-            </a:avLst>
-          </a:prstGeom>
-          <a:solidFill>
-            <a:schemeClr val="bg1">
-              <a:alpha val="22000"/>
-            </a:schemeClr>
-          </a:solidFill>
-          <a:ln/>
-        </p:spPr>
-      </p:sp>
-      <p:sp>
-        <p:nvSpPr>
-          <p:cNvPr id="19" name="Wirbel 9"/>
-          <p:cNvSpPr/>
-          <p:nvPr/>
-        </p:nvSpPr>
-        <p:spPr>
-          <a:xfrm>
-            <a:off x="9509760" y="5084064"/>
-            <a:ext cx="1371600" cy="365760"/>
-          </a:xfrm>
-          <a:prstGeom prst="roundRect">
-            <a:avLst>
-              <a:gd name="adj" fmla="val 50000"/>
-            </a:avLst>
-          </a:prstGeom>
-          <a:solidFill>
-            <a:schemeClr val="bg1">
-              <a:alpha val="22000"/>
-            </a:schemeClr>
-          </a:solidFill>
-          <a:ln/>
-        </p:spPr>
-      </p:sp>
-      <p:sp>
-        <p:nvSpPr>
-          <p:cNvPr id="20" name="Text 18"/>
+      <p:pic>
+        <p:nvPicPr>
+          <p:cNvPr id="11" name="Image 0" descr="Wirbelsäule in natürlicher S-Form, seitlich">    </p:cNvPr>
+          <p:cNvPicPr>
+            <a:picLocks noChangeAspect="1"/>
+          </p:cNvPicPr>
+          <p:nvPr/>
+        </p:nvPicPr>
+        <p:blipFill>
+          <a:blip r:embed="rId1"/>
+          <a:stretch>
+            <a:fillRect/>
+          </a:stretch>
+        </p:blipFill>
+        <p:spPr>
+          <a:xfrm>
+            <a:off x="9144000" y="548640"/>
+            <a:ext cx="2212848" cy="5029200"/>
+          </a:xfrm>
+          <a:prstGeom prst="rect">
+            <a:avLst/>
+          </a:prstGeom>
+        </p:spPr>
+      </p:pic>
+      <p:sp>
+        <p:nvSpPr>
+          <p:cNvPr id="12" name="Text 9"/>
           <p:cNvSpPr txBox="1"/>
           <p:nvPr/>
         </p:nvSpPr>
         <p:spPr>
           <a:xfrm>
-            <a:off x="9281160" y="5715000"/>
-            <a:ext cx="1828800" cy="365760"/>
+            <a:off x="8869680" y="5715000"/>
+            <a:ext cx="2743200" cy="365760"/>
           </a:xfrm>
           <a:prstGeom prst="rect">
             <a:avLst/>
@@ -9781,7 +9409,7 @@
                   <a:schemeClr val="accent2"/>
                 </a:solidFill>
               </a:rPr>
-              <a:t>Aufgerichtet</a:t>
+              <a:t>Natürliche S-Form</a:t>
             </a:r>
             <a:endParaRPr lang="en-US" sz="1100" dirty="0"/>
           </a:p>

</xml_diff>